<commit_message>
Add Playwright tests for Locked In PRIMM chapter 3 functionality
- Implement tests for story recap, predict, run, investigate, modify, and make stages.
- Validate user interactions and expected outputs for various code scenarios.
- Ensure proper handling of edge cases, including infinite loops and incorrect inputs.
- Confirm UI elements display correctly based on user actions and state changes.
</commit_message>
<xml_diff>
--- a/_presentations/Y9_Python/Y9_Python_Deck_Template.pptx
+++ b/_presentations/Y9_Python/Y9_Python_Deck_Template.pptx
@@ -142,7 +142,7 @@
   <p:extLst>
     <p:ext uri="{521415D9-36F7-43E2-AB2F-B90AF26B5E84}">
       <p14:sectionLst xmlns:p14="http://schemas.microsoft.com/office/powerpoint/2010/main">
-        <p14:section name="How to use" id="{80abaad3-6ff9-7921-e33a-d9b80033564d}">
+        <p14:section name="How to use" id="{9a6e7d1e-d5e7-44cc-de85-ec742dc79116}">
           <p14:sldIdLst>
             <p14:sldId id="256"/>
             <p14:sldId id="257"/>
@@ -153,7 +153,7 @@
             <p14:sldId id="262"/>
           </p14:sldIdLst>
         </p14:section>
-        <p14:section name="Examples" id="{e67d2947-8f2a-afa0-7279-1206c6e7f074}">
+        <p14:section name="Examples" id="{eff302eb-bf8b-0b67-ff92-d1b3d6f2e215}">
           <p14:sldIdLst>
             <p14:sldId id="263"/>
             <p14:sldId id="264"/>
@@ -175,7 +175,7 @@
             <p14:sldId id="280"/>
           </p14:sldIdLst>
         </p14:section>
-        <p14:section name="Station state" id="{c6ad35cb-c579-e8aa-50b6-5cfb229b3f11}">
+        <p14:section name="Station state" id="{7cd150e3-fc42-af90-f42c-d0f5351e89fc}">
           <p14:sldIdLst>
             <p14:sldId id="281"/>
             <p14:sldId id="282"/>
@@ -4761,7 +4761,7 @@
                 <a:ea typeface="Consolas" pitchFamily="34" charset="-122"/>
                 <a:cs typeface="Consolas" pitchFamily="34" charset="-120"/>
               </a:rPr>
-              <a:t>RULES ............ 15</a:t>
+              <a:t>RULES ............ 16</a:t>
             </a:r>
             <a:endParaRPr lang="en-US" sz="2000" dirty="0"/>
           </a:p>
@@ -42235,7 +42235,146 @@
       </p:sp>
       <p:sp>
         <p:nvSpPr>
-          <p:cNvPr id="15" name="Text 13"/>
+          <p:cNvPr id="15" name="Shape 13"/>
+          <p:cNvSpPr/>
+          <p:nvPr/>
+        </p:nvSpPr>
+        <p:spPr>
+          <a:xfrm>
+            <a:off x="548640" y="4901184"/>
+            <a:ext cx="11091672" cy="1069848"/>
+          </a:xfrm>
+          <a:prstGeom prst="roundRect">
+            <a:avLst>
+              <a:gd name="adj" fmla="val 5128"/>
+            </a:avLst>
+          </a:prstGeom>
+          <a:solidFill>
+            <a:srgbClr val="2A2A32"/>
+          </a:solidFill>
+          <a:ln/>
+        </p:spPr>
+      </p:sp>
+      <p:sp>
+        <p:nvSpPr>
+          <p:cNvPr id="16" name="Text 14"/>
+          <p:cNvSpPr txBox="1"/>
+          <p:nvPr/>
+        </p:nvSpPr>
+        <p:spPr>
+          <a:xfrm>
+            <a:off x="777240" y="5010912"/>
+            <a:ext cx="2377440" cy="411480"/>
+          </a:xfrm>
+          <a:prstGeom prst="rect">
+            <a:avLst/>
+          </a:prstGeom>
+          <a:noFill/>
+          <a:ln/>
+        </p:spPr>
+        <p:txBody>
+          <a:bodyPr wrap="square" lIns="0" tIns="0" rIns="0" bIns="0" rtlCol="0" anchor="ctr"/>
+          <a:lstStyle/>
+          <a:p>
+            <a:pPr indent="0" marL="0">
+              <a:buNone/>
+            </a:pPr>
+            <a:r>
+              <a:rPr lang="en-US" sz="1800" b="1" dirty="0">
+                <a:solidFill>
+                  <a:srgbClr val="D8A73D"/>
+                </a:solidFill>
+                <a:latin typeface="Calibri" pitchFamily="34" charset="0"/>
+                <a:ea typeface="Calibri" pitchFamily="34" charset="-122"/>
+                <a:cs typeface="Calibri" pitchFamily="34" charset="-120"/>
+              </a:rPr>
+              <a:t>Split attention</a:t>
+            </a:r>
+            <a:endParaRPr lang="en-US" sz="1800" dirty="0"/>
+          </a:p>
+        </p:txBody>
+      </p:sp>
+      <p:sp>
+        <p:nvSpPr>
+          <p:cNvPr id="17" name="Text 15"/>
+          <p:cNvSpPr txBox="1"/>
+          <p:nvPr/>
+        </p:nvSpPr>
+        <p:spPr>
+          <a:xfrm>
+            <a:off x="777240" y="5404104"/>
+            <a:ext cx="2377440" cy="274320"/>
+          </a:xfrm>
+          <a:prstGeom prst="rect">
+            <a:avLst/>
+          </a:prstGeom>
+          <a:noFill/>
+          <a:ln/>
+        </p:spPr>
+        <p:txBody>
+          <a:bodyPr wrap="square" lIns="0" tIns="0" rIns="0" bIns="0" rtlCol="0" anchor="ctr"/>
+          <a:lstStyle/>
+          <a:p>
+            <a:pPr indent="0" marL="0">
+              <a:buNone/>
+            </a:pPr>
+            <a:r>
+              <a:rPr lang="en-US" sz="1200" dirty="0">
+                <a:solidFill>
+                  <a:srgbClr val="6E6E7A"/>
+                </a:solidFill>
+                <a:latin typeface="Calibri" pitchFamily="34" charset="0"/>
+                <a:ea typeface="Calibri" pitchFamily="34" charset="-122"/>
+                <a:cs typeface="Calibri" pitchFamily="34" charset="-120"/>
+              </a:rPr>
+              <a:t>2026-10-22</a:t>
+            </a:r>
+            <a:endParaRPr lang="en-US" sz="1200" dirty="0"/>
+          </a:p>
+        </p:txBody>
+      </p:sp>
+      <p:sp>
+        <p:nvSpPr>
+          <p:cNvPr id="18" name="Text 16"/>
+          <p:cNvSpPr txBox="1"/>
+          <p:nvPr/>
+        </p:nvSpPr>
+        <p:spPr>
+          <a:xfrm>
+            <a:off x="3291840" y="4928616"/>
+            <a:ext cx="8183880" cy="1014984"/>
+          </a:xfrm>
+          <a:prstGeom prst="rect">
+            <a:avLst/>
+          </a:prstGeom>
+          <a:noFill/>
+          <a:ln/>
+        </p:spPr>
+        <p:txBody>
+          <a:bodyPr wrap="square" lIns="0" tIns="0" rIns="0" bIns="0" rtlCol="0" anchor="ctr"/>
+          <a:lstStyle/>
+          <a:p>
+            <a:pPr indent="0" marL="0">
+              <a:buNone/>
+            </a:pPr>
+            <a:r>
+              <a:rPr lang="en-US" sz="1800" dirty="0">
+                <a:solidFill>
+                  <a:srgbClr val="F5F5F3"/>
+                </a:solidFill>
+                <a:latin typeface="Calibri" pitchFamily="34" charset="0"/>
+                <a:ea typeface="Calibri" pitchFamily="34" charset="-122"/>
+                <a:cs typeface="Calibri" pitchFamily="34" charset="-120"/>
+              </a:rPr>
+              <a:t>Labels go right beside what they label: fit the code panel to the code so no label is a long arrow away, and mark the part a label names in the code itself (gold colons, spaces drawn as dots), repeated in the same colour in the label. For if / else, a green band behind the True block and an amber one behind the False block, running on behind each label (L2 slide 9, "if and else").</a:t>
+            </a:r>
+            <a:endParaRPr lang="en-US" sz="1800" dirty="0"/>
+          </a:p>
+        </p:txBody>
+      </p:sp>
+      <p:sp>
+        <p:nvSpPr>
+          <p:cNvPr id="19" name="Text 17"/>
           <p:cNvSpPr txBox="1"/>
           <p:nvPr/>
         </p:nvSpPr>

</xml_diff>